<commit_message>
chore(assets): update PPTX slide template
</commit_message>
<xml_diff>
--- a/assets/template.pptx
+++ b/assets/template.pptx
@@ -9037,8 +9037,8 @@
         </p:nvSpPr>
         <p:spPr>
           <a:xfrm>
-            <a:off x="952500" y="1648857"/>
-            <a:ext cx="11099800" cy="7213600"/>
+            <a:off x="952500" y="1877457"/>
+            <a:ext cx="11099800" cy="6985000"/>
           </a:xfrm>
           <a:prstGeom prst="rect">
             <a:avLst/>

</xml_diff>